<commit_message>
changed file extension to more appropraite type
</commit_message>
<xml_diff>
--- a/CYBER360-5.2-User-Rights.pptx
+++ b/CYBER360-5.2-User-Rights.pptx
@@ -121,147 +121,24 @@
 <file path=ppt/changesInfos/changesInfo1.xml><?xml version="1.0" encoding="utf-8"?>
 <pc:chgInfo xmlns:a="http://schemas.openxmlformats.org/drawingml/2006/main" xmlns:r="http://schemas.openxmlformats.org/officeDocument/2006/relationships" xmlns:ac="http://schemas.microsoft.com/office/drawing/2013/main/command" xmlns:pc="http://schemas.microsoft.com/office/powerpoint/2013/main/command">
   <pc:docChgLst>
-    <pc:chgData name="Talbert, Matthew" userId="877a4118-3f16-4ac9-a72c-5dd2c7b28c85" providerId="ADAL" clId="{802A71F8-08C6-448F-B24C-F083ECBD9D63}"/>
-    <pc:docChg chg="undo custSel modSld">
-      <pc:chgData name="Talbert, Matthew" userId="877a4118-3f16-4ac9-a72c-5dd2c7b28c85" providerId="ADAL" clId="{802A71F8-08C6-448F-B24C-F083ECBD9D63}" dt="2024-11-21T23:29:19.232" v="247" actId="12788"/>
+    <pc:chgData name="Lindstrom, Craig" userId="9231af9e-1897-4c08-9c5d-ac4532ae2341" providerId="ADAL" clId="{C1B137FC-312E-4977-9472-B55062C29CD7}"/>
+    <pc:docChg chg="modSld">
+      <pc:chgData name="Lindstrom, Craig" userId="9231af9e-1897-4c08-9c5d-ac4532ae2341" providerId="ADAL" clId="{C1B137FC-312E-4977-9472-B55062C29CD7}" dt="2026-03-03T14:11:27.841" v="5" actId="20577"/>
       <pc:docMkLst>
         <pc:docMk/>
       </pc:docMkLst>
       <pc:sldChg chg="modSp mod">
-        <pc:chgData name="Talbert, Matthew" userId="877a4118-3f16-4ac9-a72c-5dd2c7b28c85" providerId="ADAL" clId="{802A71F8-08C6-448F-B24C-F083ECBD9D63}" dt="2024-11-21T23:26:28.494" v="6" actId="12788"/>
-        <pc:sldMkLst>
-          <pc:docMk/>
-          <pc:sldMk cId="2312486803" sldId="258"/>
-        </pc:sldMkLst>
-        <pc:spChg chg="mod">
-          <ac:chgData name="Talbert, Matthew" userId="877a4118-3f16-4ac9-a72c-5dd2c7b28c85" providerId="ADAL" clId="{802A71F8-08C6-448F-B24C-F083ECBD9D63}" dt="2024-11-21T23:26:28.494" v="6" actId="12788"/>
-          <ac:spMkLst>
-            <pc:docMk/>
-            <pc:sldMk cId="2312486803" sldId="258"/>
-            <ac:spMk id="2" creationId="{31B75992-5098-A283-4925-2CCEBB801DC5}"/>
-          </ac:spMkLst>
-        </pc:spChg>
-        <pc:picChg chg="mod">
-          <ac:chgData name="Talbert, Matthew" userId="877a4118-3f16-4ac9-a72c-5dd2c7b28c85" providerId="ADAL" clId="{802A71F8-08C6-448F-B24C-F083ECBD9D63}" dt="2024-11-21T23:26:28.494" v="6" actId="12788"/>
-          <ac:picMkLst>
-            <pc:docMk/>
-            <pc:sldMk cId="2312486803" sldId="258"/>
-            <ac:picMk id="3" creationId="{18F1AD7D-9AA4-CABA-2192-FD95BCEAD031}"/>
-          </ac:picMkLst>
-        </pc:picChg>
-      </pc:sldChg>
-      <pc:sldChg chg="modSp mod">
-        <pc:chgData name="Talbert, Matthew" userId="877a4118-3f16-4ac9-a72c-5dd2c7b28c85" providerId="ADAL" clId="{802A71F8-08C6-448F-B24C-F083ECBD9D63}" dt="2024-11-21T23:26:47.821" v="96" actId="1035"/>
-        <pc:sldMkLst>
-          <pc:docMk/>
-          <pc:sldMk cId="1196559129" sldId="259"/>
-        </pc:sldMkLst>
-        <pc:spChg chg="mod">
-          <ac:chgData name="Talbert, Matthew" userId="877a4118-3f16-4ac9-a72c-5dd2c7b28c85" providerId="ADAL" clId="{802A71F8-08C6-448F-B24C-F083ECBD9D63}" dt="2024-11-21T23:26:42.181" v="69" actId="1036"/>
-          <ac:spMkLst>
-            <pc:docMk/>
-            <pc:sldMk cId="1196559129" sldId="259"/>
-            <ac:spMk id="2" creationId="{0E6A2DEF-4501-FAEA-A31C-4FDCBD076712}"/>
-          </ac:spMkLst>
-        </pc:spChg>
-        <pc:spChg chg="mod">
-          <ac:chgData name="Talbert, Matthew" userId="877a4118-3f16-4ac9-a72c-5dd2c7b28c85" providerId="ADAL" clId="{802A71F8-08C6-448F-B24C-F083ECBD9D63}" dt="2024-11-21T23:26:47.821" v="96" actId="1035"/>
-          <ac:spMkLst>
-            <pc:docMk/>
-            <pc:sldMk cId="1196559129" sldId="259"/>
-            <ac:spMk id="7" creationId="{4247D23F-F3F9-676F-BDEB-E69E1F0AB32C}"/>
-          </ac:spMkLst>
-        </pc:spChg>
-      </pc:sldChg>
-      <pc:sldChg chg="modSp mod">
-        <pc:chgData name="Talbert, Matthew" userId="877a4118-3f16-4ac9-a72c-5dd2c7b28c85" providerId="ADAL" clId="{802A71F8-08C6-448F-B24C-F083ECBD9D63}" dt="2024-11-21T23:27:35.079" v="118" actId="12788"/>
-        <pc:sldMkLst>
-          <pc:docMk/>
-          <pc:sldMk cId="1400208519" sldId="260"/>
-        </pc:sldMkLst>
-        <pc:spChg chg="mod">
-          <ac:chgData name="Talbert, Matthew" userId="877a4118-3f16-4ac9-a72c-5dd2c7b28c85" providerId="ADAL" clId="{802A71F8-08C6-448F-B24C-F083ECBD9D63}" dt="2024-11-21T23:27:35.079" v="118" actId="12788"/>
-          <ac:spMkLst>
-            <pc:docMk/>
-            <pc:sldMk cId="1400208519" sldId="260"/>
-            <ac:spMk id="2" creationId="{832B45BA-6309-D8F6-D552-10D836B4EB21}"/>
-          </ac:spMkLst>
-        </pc:spChg>
-        <pc:spChg chg="mod">
-          <ac:chgData name="Talbert, Matthew" userId="877a4118-3f16-4ac9-a72c-5dd2c7b28c85" providerId="ADAL" clId="{802A71F8-08C6-448F-B24C-F083ECBD9D63}" dt="2024-11-21T23:27:35.079" v="118" actId="12788"/>
-          <ac:spMkLst>
-            <pc:docMk/>
-            <pc:sldMk cId="1400208519" sldId="260"/>
-            <ac:spMk id="7" creationId="{3CE889EF-4605-DB73-C7B2-D7E3C4957F48}"/>
-          </ac:spMkLst>
-        </pc:spChg>
-      </pc:sldChg>
-      <pc:sldChg chg="modSp mod">
-        <pc:chgData name="Talbert, Matthew" userId="877a4118-3f16-4ac9-a72c-5dd2c7b28c85" providerId="ADAL" clId="{802A71F8-08C6-448F-B24C-F083ECBD9D63}" dt="2024-11-21T23:27:51.644" v="156" actId="1036"/>
-        <pc:sldMkLst>
-          <pc:docMk/>
-          <pc:sldMk cId="1959728496" sldId="261"/>
-        </pc:sldMkLst>
-        <pc:spChg chg="mod">
-          <ac:chgData name="Talbert, Matthew" userId="877a4118-3f16-4ac9-a72c-5dd2c7b28c85" providerId="ADAL" clId="{802A71F8-08C6-448F-B24C-F083ECBD9D63}" dt="2024-11-21T23:27:46.843" v="147" actId="1036"/>
-          <ac:spMkLst>
-            <pc:docMk/>
-            <pc:sldMk cId="1959728496" sldId="261"/>
-            <ac:spMk id="2" creationId="{CE563C74-E990-3B77-1F46-668B8C1F1663}"/>
-          </ac:spMkLst>
-        </pc:spChg>
-        <pc:spChg chg="mod">
-          <ac:chgData name="Talbert, Matthew" userId="877a4118-3f16-4ac9-a72c-5dd2c7b28c85" providerId="ADAL" clId="{802A71F8-08C6-448F-B24C-F083ECBD9D63}" dt="2024-11-21T23:27:51.644" v="156" actId="1036"/>
-          <ac:spMkLst>
-            <pc:docMk/>
-            <pc:sldMk cId="1959728496" sldId="261"/>
-            <ac:spMk id="7" creationId="{90027281-906B-E8EC-9F0D-DB9DF0665C9C}"/>
-          </ac:spMkLst>
-        </pc:spChg>
-      </pc:sldChg>
-      <pc:sldChg chg="modSp mod">
-        <pc:chgData name="Talbert, Matthew" userId="877a4118-3f16-4ac9-a72c-5dd2c7b28c85" providerId="ADAL" clId="{802A71F8-08C6-448F-B24C-F083ECBD9D63}" dt="2024-11-21T23:28:06.966" v="167" actId="1036"/>
+        <pc:chgData name="Lindstrom, Craig" userId="9231af9e-1897-4c08-9c5d-ac4532ae2341" providerId="ADAL" clId="{C1B137FC-312E-4977-9472-B55062C29CD7}" dt="2026-03-03T14:11:27.841" v="5" actId="20577"/>
         <pc:sldMkLst>
           <pc:docMk/>
           <pc:sldMk cId="538849350" sldId="262"/>
         </pc:sldMkLst>
         <pc:spChg chg="mod">
-          <ac:chgData name="Talbert, Matthew" userId="877a4118-3f16-4ac9-a72c-5dd2c7b28c85" providerId="ADAL" clId="{802A71F8-08C6-448F-B24C-F083ECBD9D63}" dt="2024-11-21T23:28:06.966" v="167" actId="1036"/>
-          <ac:spMkLst>
-            <pc:docMk/>
-            <pc:sldMk cId="538849350" sldId="262"/>
-            <ac:spMk id="2" creationId="{3D63CD28-05F6-EAAC-4E88-DBFBCF6B207B}"/>
-          </ac:spMkLst>
-        </pc:spChg>
-        <pc:spChg chg="mod">
-          <ac:chgData name="Talbert, Matthew" userId="877a4118-3f16-4ac9-a72c-5dd2c7b28c85" providerId="ADAL" clId="{802A71F8-08C6-448F-B24C-F083ECBD9D63}" dt="2024-11-21T23:28:04.166" v="164" actId="1036"/>
+          <ac:chgData name="Lindstrom, Craig" userId="9231af9e-1897-4c08-9c5d-ac4532ae2341" providerId="ADAL" clId="{C1B137FC-312E-4977-9472-B55062C29CD7}" dt="2026-03-03T14:11:27.841" v="5" actId="20577"/>
           <ac:spMkLst>
             <pc:docMk/>
             <pc:sldMk cId="538849350" sldId="262"/>
             <ac:spMk id="7" creationId="{729440C3-A558-AF83-79BF-585206231CA4}"/>
-          </ac:spMkLst>
-        </pc:spChg>
-      </pc:sldChg>
-      <pc:sldChg chg="modSp mod">
-        <pc:chgData name="Talbert, Matthew" userId="877a4118-3f16-4ac9-a72c-5dd2c7b28c85" providerId="ADAL" clId="{802A71F8-08C6-448F-B24C-F083ECBD9D63}" dt="2024-11-21T23:29:19.232" v="247" actId="12788"/>
-        <pc:sldMkLst>
-          <pc:docMk/>
-          <pc:sldMk cId="3885141102" sldId="263"/>
-        </pc:sldMkLst>
-        <pc:spChg chg="mod">
-          <ac:chgData name="Talbert, Matthew" userId="877a4118-3f16-4ac9-a72c-5dd2c7b28c85" providerId="ADAL" clId="{802A71F8-08C6-448F-B24C-F083ECBD9D63}" dt="2024-11-21T23:29:19.232" v="247" actId="12788"/>
-          <ac:spMkLst>
-            <pc:docMk/>
-            <pc:sldMk cId="3885141102" sldId="263"/>
-            <ac:spMk id="2" creationId="{31B75992-5098-A283-4925-2CCEBB801DC5}"/>
-          </ac:spMkLst>
-        </pc:spChg>
-        <pc:spChg chg="mod">
-          <ac:chgData name="Talbert, Matthew" userId="877a4118-3f16-4ac9-a72c-5dd2c7b28c85" providerId="ADAL" clId="{802A71F8-08C6-448F-B24C-F083ECBD9D63}" dt="2024-11-21T23:29:19.232" v="247" actId="12788"/>
-          <ac:spMkLst>
-            <pc:docMk/>
-            <pc:sldMk cId="3885141102" sldId="263"/>
-            <ac:spMk id="3" creationId="{B5924E0F-A977-1710-779D-EEB74261AF34}"/>
           </ac:spMkLst>
         </pc:spChg>
       </pc:sldChg>
@@ -449,7 +326,7 @@
           <a:p>
             <a:fld id="{71087A05-F855-4434-8DDE-39A8542098A6}" type="datetimeFigureOut">
               <a:rPr lang="en-US" smtClean="0"/>
-              <a:t>3/4/2025</a:t>
+              <a:t>3/3/2026</a:t>
             </a:fld>
             <a:endParaRPr lang="en-US"/>
           </a:p>
@@ -687,7 +564,7 @@
           <a:p>
             <a:fld id="{71087A05-F855-4434-8DDE-39A8542098A6}" type="datetimeFigureOut">
               <a:rPr lang="en-US" smtClean="0"/>
-              <a:t>3/4/2025</a:t>
+              <a:t>3/3/2026</a:t>
             </a:fld>
             <a:endParaRPr lang="en-US"/>
           </a:p>
@@ -923,7 +800,7 @@
           <a:p>
             <a:fld id="{421996D4-4A1C-4BBC-AA2B-FD5B7FC395A0}" type="datetime1">
               <a:rPr lang="en-US" smtClean="0"/>
-              <a:t>3/4/2025</a:t>
+              <a:t>3/3/2026</a:t>
             </a:fld>
             <a:endParaRPr lang="en-US"/>
           </a:p>
@@ -1226,7 +1103,7 @@
           <a:p>
             <a:fld id="{71087A05-F855-4434-8DDE-39A8542098A6}" type="datetimeFigureOut">
               <a:rPr lang="en-US" smtClean="0"/>
-              <a:t>3/4/2025</a:t>
+              <a:t>3/3/2026</a:t>
             </a:fld>
             <a:endParaRPr lang="en-US"/>
           </a:p>
@@ -1531,7 +1408,7 @@
           <a:p>
             <a:fld id="{71087A05-F855-4434-8DDE-39A8542098A6}" type="datetimeFigureOut">
               <a:rPr lang="en-US" smtClean="0"/>
-              <a:t>3/4/2025</a:t>
+              <a:t>3/3/2026</a:t>
             </a:fld>
             <a:endParaRPr lang="en-US"/>
           </a:p>
@@ -1834,7 +1711,7 @@
           <a:p>
             <a:fld id="{71087A05-F855-4434-8DDE-39A8542098A6}" type="datetimeFigureOut">
               <a:rPr lang="en-US" smtClean="0"/>
-              <a:t>3/4/2025</a:t>
+              <a:t>3/3/2026</a:t>
             </a:fld>
             <a:endParaRPr lang="en-US"/>
           </a:p>
@@ -2285,7 +2162,7 @@
           <a:p>
             <a:fld id="{71087A05-F855-4434-8DDE-39A8542098A6}" type="datetimeFigureOut">
               <a:rPr lang="en-US" smtClean="0"/>
-              <a:t>3/4/2025</a:t>
+              <a:t>3/3/2026</a:t>
             </a:fld>
             <a:endParaRPr lang="en-US"/>
           </a:p>
@@ -2458,7 +2335,7 @@
           <a:p>
             <a:fld id="{71087A05-F855-4434-8DDE-39A8542098A6}" type="datetimeFigureOut">
               <a:rPr lang="en-US" smtClean="0"/>
-              <a:t>3/4/2025</a:t>
+              <a:t>3/3/2026</a:t>
             </a:fld>
             <a:endParaRPr lang="en-US"/>
           </a:p>
@@ -2595,7 +2472,7 @@
           <a:p>
             <a:fld id="{71087A05-F855-4434-8DDE-39A8542098A6}" type="datetimeFigureOut">
               <a:rPr lang="en-US" smtClean="0"/>
-              <a:t>3/4/2025</a:t>
+              <a:t>3/3/2026</a:t>
             </a:fld>
             <a:endParaRPr lang="en-US"/>
           </a:p>
@@ -2939,7 +2816,7 @@
           <a:p>
             <a:fld id="{71087A05-F855-4434-8DDE-39A8542098A6}" type="datetimeFigureOut">
               <a:rPr lang="en-US" smtClean="0"/>
-              <a:t>3/4/2025</a:t>
+              <a:t>3/3/2026</a:t>
             </a:fld>
             <a:endParaRPr lang="en-US"/>
           </a:p>
@@ -3263,7 +3140,7 @@
           <a:p>
             <a:fld id="{71087A05-F855-4434-8DDE-39A8542098A6}" type="datetimeFigureOut">
               <a:rPr lang="en-US" smtClean="0"/>
-              <a:t>3/4/2025</a:t>
+              <a:t>3/3/2026</a:t>
             </a:fld>
             <a:endParaRPr lang="en-US"/>
           </a:p>
@@ -4734,8 +4611,17 @@
               <a:rPr lang="en-US" dirty="0">
                 <a:latin typeface="Lucida Console" panose="020B0609040504020204" pitchFamily="49" charset="0"/>
               </a:rPr>
-              <a:t> C:\Temp\secedit.txt</a:t>
-            </a:r>
+              <a:t> C:\Temp\</a:t>
+            </a:r>
+            <a:r>
+              <a:rPr lang="en-US">
+                <a:latin typeface="Lucida Console" panose="020B0609040504020204" pitchFamily="49" charset="0"/>
+              </a:rPr>
+              <a:t>secedit.ini</a:t>
+            </a:r>
+            <a:endParaRPr lang="en-US" dirty="0">
+              <a:latin typeface="Lucida Console" panose="020B0609040504020204" pitchFamily="49" charset="0"/>
+            </a:endParaRPr>
           </a:p>
           <a:p>
             <a:endParaRPr lang="en-US" dirty="0"/>

</xml_diff>